<commit_message>
Removed animation from chair slides
</commit_message>
<xml_diff>
--- a/126/slides/slides-126-nmop-chair-slides-session1.pptx
+++ b/126/slides/slides-126-nmop-chair-slides-session1.pptx
@@ -279,182 +279,6 @@
     <p1510:client id="{AA659D06-233B-4A84-BAB1-FC917D228196}" v="7" dt="2026-03-16T00:35:04.726"/>
   </p1510:revLst>
 </p1510:revInfo>
-</file>
-
-<file path=ppt/changesInfos/changesInfo1.xml><?xml version="1.0" encoding="utf-8"?>
-<pc:chgInfo xmlns:a="http://schemas.openxmlformats.org/drawingml/2006/main" xmlns:r="http://schemas.openxmlformats.org/officeDocument/2006/relationships" xmlns:ac="http://schemas.microsoft.com/office/drawing/2013/main/command" xmlns:pc="http://schemas.microsoft.com/office/powerpoint/2013/main/command">
-  <pc:docChgLst>
-    <pc:chgData name="Graf Thomas, SCS-INI-NET-VNC-E2E" userId="487bc3e3-9ce7-4cdd-b7b4-8899ea88d289" providerId="ADAL" clId="{ADEEF08A-D719-4B50-A383-4105EDA2C206}"/>
-    <pc:docChg chg="custSel mod addSld delSld modSld">
-      <pc:chgData name="Graf Thomas, SCS-INI-NET-VNC-E2E" userId="487bc3e3-9ce7-4cdd-b7b4-8899ea88d289" providerId="ADAL" clId="{ADEEF08A-D719-4B50-A383-4105EDA2C206}" dt="2026-03-16T00:34:54.732" v="33" actId="20577"/>
-      <pc:docMkLst>
-        <pc:docMk/>
-      </pc:docMkLst>
-      <pc:sldChg chg="del">
-        <pc:chgData name="Graf Thomas, SCS-INI-NET-VNC-E2E" userId="487bc3e3-9ce7-4cdd-b7b4-8899ea88d289" providerId="ADAL" clId="{ADEEF08A-D719-4B50-A383-4105EDA2C206}" dt="2026-03-16T00:33:00.591" v="26" actId="47"/>
-        <pc:sldMkLst>
-          <pc:docMk/>
-          <pc:sldMk cId="0" sldId="258"/>
-        </pc:sldMkLst>
-      </pc:sldChg>
-      <pc:sldChg chg="add">
-        <pc:chgData name="Graf Thomas, SCS-INI-NET-VNC-E2E" userId="487bc3e3-9ce7-4cdd-b7b4-8899ea88d289" providerId="ADAL" clId="{ADEEF08A-D719-4B50-A383-4105EDA2C206}" dt="2026-03-16T00:34:31.635" v="27"/>
-        <pc:sldMkLst>
-          <pc:docMk/>
-          <pc:sldMk cId="0" sldId="259"/>
-        </pc:sldMkLst>
-      </pc:sldChg>
-      <pc:sldChg chg="add">
-        <pc:chgData name="Graf Thomas, SCS-INI-NET-VNC-E2E" userId="487bc3e3-9ce7-4cdd-b7b4-8899ea88d289" providerId="ADAL" clId="{ADEEF08A-D719-4B50-A383-4105EDA2C206}" dt="2026-03-16T00:31:09.369" v="19"/>
-        <pc:sldMkLst>
-          <pc:docMk/>
-          <pc:sldMk cId="0" sldId="260"/>
-        </pc:sldMkLst>
-      </pc:sldChg>
-      <pc:sldChg chg="modSp add mod">
-        <pc:chgData name="Graf Thomas, SCS-INI-NET-VNC-E2E" userId="487bc3e3-9ce7-4cdd-b7b4-8899ea88d289" providerId="ADAL" clId="{ADEEF08A-D719-4B50-A383-4105EDA2C206}" dt="2026-03-16T00:34:54.732" v="33" actId="20577"/>
-        <pc:sldMkLst>
-          <pc:docMk/>
-          <pc:sldMk cId="3471097262" sldId="261"/>
-        </pc:sldMkLst>
-        <pc:spChg chg="mod">
-          <ac:chgData name="Graf Thomas, SCS-INI-NET-VNC-E2E" userId="487bc3e3-9ce7-4cdd-b7b4-8899ea88d289" providerId="ADAL" clId="{ADEEF08A-D719-4B50-A383-4105EDA2C206}" dt="2026-03-16T00:34:54.732" v="33" actId="20577"/>
-          <ac:spMkLst>
-            <pc:docMk/>
-            <pc:sldMk cId="3471097262" sldId="261"/>
-            <ac:spMk id="3" creationId="{DA4A6F5D-9442-B583-BAB9-5A102B90EC22}"/>
-          </ac:spMkLst>
-        </pc:spChg>
-      </pc:sldChg>
-      <pc:sldChg chg="modSp mod">
-        <pc:chgData name="Graf Thomas, SCS-INI-NET-VNC-E2E" userId="487bc3e3-9ce7-4cdd-b7b4-8899ea88d289" providerId="ADAL" clId="{ADEEF08A-D719-4B50-A383-4105EDA2C206}" dt="2026-03-16T00:26:03.620" v="12" actId="20577"/>
-        <pc:sldMkLst>
-          <pc:docMk/>
-          <pc:sldMk cId="0" sldId="276"/>
-        </pc:sldMkLst>
-        <pc:spChg chg="mod">
-          <ac:chgData name="Graf Thomas, SCS-INI-NET-VNC-E2E" userId="487bc3e3-9ce7-4cdd-b7b4-8899ea88d289" providerId="ADAL" clId="{ADEEF08A-D719-4B50-A383-4105EDA2C206}" dt="2026-03-16T00:26:03.620" v="12" actId="20577"/>
-          <ac:spMkLst>
-            <pc:docMk/>
-            <pc:sldMk cId="0" sldId="276"/>
-            <ac:spMk id="100" creationId="{00000000-0000-0000-0000-000000000000}"/>
-          </ac:spMkLst>
-        </pc:spChg>
-      </pc:sldChg>
-      <pc:sldChg chg="del">
-        <pc:chgData name="Graf Thomas, SCS-INI-NET-VNC-E2E" userId="487bc3e3-9ce7-4cdd-b7b4-8899ea88d289" providerId="ADAL" clId="{ADEEF08A-D719-4B50-A383-4105EDA2C206}" dt="2026-03-16T00:30:25.888" v="18" actId="47"/>
-        <pc:sldMkLst>
-          <pc:docMk/>
-          <pc:sldMk cId="4020374104" sldId="277"/>
-        </pc:sldMkLst>
-      </pc:sldChg>
-      <pc:sldChg chg="addSp delSp modSp mod">
-        <pc:chgData name="Graf Thomas, SCS-INI-NET-VNC-E2E" userId="487bc3e3-9ce7-4cdd-b7b4-8899ea88d289" providerId="ADAL" clId="{ADEEF08A-D719-4B50-A383-4105EDA2C206}" dt="2026-03-16T00:29:44.360" v="17" actId="14100"/>
-        <pc:sldMkLst>
-          <pc:docMk/>
-          <pc:sldMk cId="3873870168" sldId="278"/>
-        </pc:sldMkLst>
-        <pc:picChg chg="del">
-          <ac:chgData name="Graf Thomas, SCS-INI-NET-VNC-E2E" userId="487bc3e3-9ce7-4cdd-b7b4-8899ea88d289" providerId="ADAL" clId="{ADEEF08A-D719-4B50-A383-4105EDA2C206}" dt="2026-03-16T00:29:35.280" v="14" actId="478"/>
-          <ac:picMkLst>
-            <pc:docMk/>
-            <pc:sldMk cId="3873870168" sldId="278"/>
-            <ac:picMk id="3" creationId="{1FE22749-978F-230A-2C82-B42414055769}"/>
-          </ac:picMkLst>
-        </pc:picChg>
-        <pc:picChg chg="add mod">
-          <ac:chgData name="Graf Thomas, SCS-INI-NET-VNC-E2E" userId="487bc3e3-9ce7-4cdd-b7b4-8899ea88d289" providerId="ADAL" clId="{ADEEF08A-D719-4B50-A383-4105EDA2C206}" dt="2026-03-16T00:29:44.360" v="17" actId="14100"/>
-          <ac:picMkLst>
-            <pc:docMk/>
-            <pc:sldMk cId="3873870168" sldId="278"/>
-            <ac:picMk id="5" creationId="{0A3BAF73-6291-808C-D649-3286010A1023}"/>
-          </ac:picMkLst>
-        </pc:picChg>
-      </pc:sldChg>
-      <pc:sldChg chg="modSp del mod">
-        <pc:chgData name="Graf Thomas, SCS-INI-NET-VNC-E2E" userId="487bc3e3-9ce7-4cdd-b7b4-8899ea88d289" providerId="ADAL" clId="{ADEEF08A-D719-4B50-A383-4105EDA2C206}" dt="2026-03-16T00:34:34.267" v="28" actId="47"/>
-        <pc:sldMkLst>
-          <pc:docMk/>
-          <pc:sldMk cId="1619678016" sldId="280"/>
-        </pc:sldMkLst>
-        <pc:spChg chg="mod">
-          <ac:chgData name="Graf Thomas, SCS-INI-NET-VNC-E2E" userId="487bc3e3-9ce7-4cdd-b7b4-8899ea88d289" providerId="ADAL" clId="{ADEEF08A-D719-4B50-A383-4105EDA2C206}" dt="2026-03-16T00:26:20.766" v="13" actId="20577"/>
-          <ac:spMkLst>
-            <pc:docMk/>
-            <pc:sldMk cId="1619678016" sldId="280"/>
-            <ac:spMk id="69" creationId="{E1870915-5CC2-61FE-6865-3145DCF074BE}"/>
-          </ac:spMkLst>
-        </pc:spChg>
-      </pc:sldChg>
-      <pc:sldChg chg="add del">
-        <pc:chgData name="Graf Thomas, SCS-INI-NET-VNC-E2E" userId="487bc3e3-9ce7-4cdd-b7b4-8899ea88d289" providerId="ADAL" clId="{ADEEF08A-D719-4B50-A383-4105EDA2C206}" dt="2026-03-16T00:32:58.385" v="25"/>
-        <pc:sldMkLst>
-          <pc:docMk/>
-          <pc:sldMk cId="0" sldId="281"/>
-        </pc:sldMkLst>
-      </pc:sldChg>
-      <pc:sldChg chg="delSp add del mod">
-        <pc:chgData name="Graf Thomas, SCS-INI-NET-VNC-E2E" userId="487bc3e3-9ce7-4cdd-b7b4-8899ea88d289" providerId="ADAL" clId="{ADEEF08A-D719-4B50-A383-4105EDA2C206}" dt="2026-03-16T00:32:51.261" v="24" actId="47"/>
-        <pc:sldMkLst>
-          <pc:docMk/>
-          <pc:sldMk cId="609936168" sldId="281"/>
-        </pc:sldMkLst>
-        <pc:picChg chg="del">
-          <ac:chgData name="Graf Thomas, SCS-INI-NET-VNC-E2E" userId="487bc3e3-9ce7-4cdd-b7b4-8899ea88d289" providerId="ADAL" clId="{ADEEF08A-D719-4B50-A383-4105EDA2C206}" dt="2026-03-16T00:32:34.879" v="23" actId="478"/>
-          <ac:picMkLst>
-            <pc:docMk/>
-            <pc:sldMk cId="609936168" sldId="281"/>
-            <ac:picMk id="71" creationId="{F8BD4ADA-9CD0-55D7-76AE-75E246A971E0}"/>
-          </ac:picMkLst>
-        </pc:picChg>
-      </pc:sldChg>
-      <pc:sldChg chg="del">
-        <pc:chgData name="Graf Thomas, SCS-INI-NET-VNC-E2E" userId="487bc3e3-9ce7-4cdd-b7b4-8899ea88d289" providerId="ADAL" clId="{ADEEF08A-D719-4B50-A383-4105EDA2C206}" dt="2026-03-16T00:30:25.888" v="18" actId="47"/>
-        <pc:sldMkLst>
-          <pc:docMk/>
-          <pc:sldMk cId="1293646540" sldId="281"/>
-        </pc:sldMkLst>
-      </pc:sldChg>
-      <pc:sldChg chg="del">
-        <pc:chgData name="Graf Thomas, SCS-INI-NET-VNC-E2E" userId="487bc3e3-9ce7-4cdd-b7b4-8899ea88d289" providerId="ADAL" clId="{ADEEF08A-D719-4B50-A383-4105EDA2C206}" dt="2026-03-16T00:30:25.888" v="18" actId="47"/>
-        <pc:sldMkLst>
-          <pc:docMk/>
-          <pc:sldMk cId="1765196037" sldId="282"/>
-        </pc:sldMkLst>
-      </pc:sldChg>
-      <pc:sldChg chg="del">
-        <pc:chgData name="Graf Thomas, SCS-INI-NET-VNC-E2E" userId="487bc3e3-9ce7-4cdd-b7b4-8899ea88d289" providerId="ADAL" clId="{ADEEF08A-D719-4B50-A383-4105EDA2C206}" dt="2026-03-16T00:30:25.888" v="18" actId="47"/>
-        <pc:sldMkLst>
-          <pc:docMk/>
-          <pc:sldMk cId="385604894" sldId="283"/>
-        </pc:sldMkLst>
-      </pc:sldChg>
-      <pc:sldMasterChg chg="delSldLayout">
-        <pc:chgData name="Graf Thomas, SCS-INI-NET-VNC-E2E" userId="487bc3e3-9ce7-4cdd-b7b4-8899ea88d289" providerId="ADAL" clId="{ADEEF08A-D719-4B50-A383-4105EDA2C206}" dt="2026-03-16T00:33:00.591" v="26" actId="47"/>
-        <pc:sldMasterMkLst>
-          <pc:docMk/>
-          <pc:sldMasterMk cId="0" sldId="2147483664"/>
-        </pc:sldMasterMkLst>
-        <pc:sldLayoutChg chg="del">
-          <pc:chgData name="Graf Thomas, SCS-INI-NET-VNC-E2E" userId="487bc3e3-9ce7-4cdd-b7b4-8899ea88d289" providerId="ADAL" clId="{ADEEF08A-D719-4B50-A383-4105EDA2C206}" dt="2026-03-16T00:30:25.888" v="18" actId="47"/>
-          <pc:sldLayoutMkLst>
-            <pc:docMk/>
-            <pc:sldMasterMk cId="0" sldId="2147483664"/>
-            <pc:sldLayoutMk cId="0" sldId="2147483649"/>
-          </pc:sldLayoutMkLst>
-        </pc:sldLayoutChg>
-        <pc:sldLayoutChg chg="del">
-          <pc:chgData name="Graf Thomas, SCS-INI-NET-VNC-E2E" userId="487bc3e3-9ce7-4cdd-b7b4-8899ea88d289" providerId="ADAL" clId="{ADEEF08A-D719-4B50-A383-4105EDA2C206}" dt="2026-03-16T00:33:00.591" v="26" actId="47"/>
-          <pc:sldLayoutMkLst>
-            <pc:docMk/>
-            <pc:sldMasterMk cId="0" sldId="2147483664"/>
-            <pc:sldLayoutMk cId="545161684" sldId="2147483666"/>
-          </pc:sldLayoutMkLst>
-        </pc:sldLayoutChg>
-      </pc:sldMasterChg>
-    </pc:docChg>
-  </pc:docChgLst>
-</pc:chgInfo>
 </file>
 
 <file path=ppt/ink/ink1.xml><?xml version="1.0" encoding="utf-8"?>
@@ -1790,556 +1614,6 @@
             <a:noAutofit/>
           </a:bodyPr>
           <a:lstStyle/>
-          <a:p>
-            <a:pPr marL="0" lvl="0" indent="0" algn="l" rtl="0">
-              <a:lnSpc>
-                <a:spcPct val="115000"/>
-              </a:lnSpc>
-              <a:spcBef>
-                <a:spcPts val="0"/>
-              </a:spcBef>
-              <a:spcAft>
-                <a:spcPts val="0"/>
-              </a:spcAft>
-              <a:buNone/>
-            </a:pPr>
-            <a:r>
-              <a:rPr lang="en-US" sz="1200" dirty="0">
-                <a:solidFill>
-                  <a:srgbClr val="424242"/>
-                </a:solidFill>
-                <a:highlight>
-                  <a:srgbClr val="FFFFFF"/>
-                </a:highlight>
-                <a:latin typeface="Roboto"/>
-                <a:ea typeface="Roboto"/>
-                <a:cs typeface="Roboto"/>
-                <a:sym typeface="Roboto"/>
-              </a:rPr>
-              <a:t>The IETF Note Well should be shown at the start of every IETF working session. The guidance below is </a:t>
-            </a:r>
-            <a:r>
-              <a:rPr lang="en-US" sz="1200" u="sng" dirty="0">
-                <a:solidFill>
-                  <a:srgbClr val="1976D2"/>
-                </a:solidFill>
-                <a:latin typeface="Roboto"/>
-                <a:ea typeface="Roboto"/>
-                <a:cs typeface="Roboto"/>
-                <a:sym typeface="Roboto"/>
-                <a:hlinkClick r:id="rId3">
-                  <a:extLst>
-                    <a:ext uri="{A12FA001-AC4F-418D-AE19-62706E023703}">
-                      <ahyp:hlinkClr xmlns:ahyp="http://schemas.microsoft.com/office/drawing/2018/hyperlinkcolor" val="tx"/>
-                    </a:ext>
-                  </a:extLst>
-                </a:hlinkClick>
-              </a:rPr>
-              <a:t>adapted from IETF legal counsel presentation during IETF 120</a:t>
-            </a:r>
-            <a:endParaRPr sz="1200" dirty="0">
-              <a:solidFill>
-                <a:srgbClr val="1B5E20"/>
-              </a:solidFill>
-              <a:highlight>
-                <a:srgbClr val="E8F5E9"/>
-              </a:highlight>
-              <a:latin typeface="Roboto"/>
-              <a:ea typeface="Roboto"/>
-              <a:cs typeface="Roboto"/>
-              <a:sym typeface="Roboto"/>
-            </a:endParaRPr>
-          </a:p>
-          <a:p>
-            <a:pPr marL="0" lvl="0" indent="0" algn="l" rtl="0">
-              <a:lnSpc>
-                <a:spcPct val="115000"/>
-              </a:lnSpc>
-              <a:spcBef>
-                <a:spcPts val="0"/>
-              </a:spcBef>
-              <a:spcAft>
-                <a:spcPts val="0"/>
-              </a:spcAft>
-              <a:buNone/>
-            </a:pPr>
-            <a:endParaRPr sz="1200" dirty="0">
-              <a:solidFill>
-                <a:srgbClr val="1B5E20"/>
-              </a:solidFill>
-              <a:highlight>
-                <a:srgbClr val="E8F5E9"/>
-              </a:highlight>
-              <a:latin typeface="Roboto"/>
-              <a:ea typeface="Roboto"/>
-              <a:cs typeface="Roboto"/>
-              <a:sym typeface="Roboto"/>
-            </a:endParaRPr>
-          </a:p>
-          <a:p>
-            <a:pPr marL="0" lvl="0" indent="0" algn="l" rtl="0">
-              <a:lnSpc>
-                <a:spcPct val="115000"/>
-              </a:lnSpc>
-              <a:spcBef>
-                <a:spcPts val="0"/>
-              </a:spcBef>
-              <a:spcAft>
-                <a:spcPts val="0"/>
-              </a:spcAft>
-              <a:buClr>
-                <a:schemeClr val="dk1"/>
-              </a:buClr>
-              <a:buSzPts val="1100"/>
-              <a:buFont typeface="Arial"/>
-              <a:buNone/>
-            </a:pPr>
-            <a:r>
-              <a:rPr lang="en-US" sz="1200" dirty="0">
-                <a:solidFill>
-                  <a:srgbClr val="1B5E20"/>
-                </a:solidFill>
-                <a:highlight>
-                  <a:srgbClr val="E8F5E9"/>
-                </a:highlight>
-                <a:latin typeface="Roboto"/>
-                <a:ea typeface="Roboto"/>
-                <a:cs typeface="Roboto"/>
-                <a:sym typeface="Roboto"/>
-              </a:rPr>
-              <a:t>DO</a:t>
-            </a:r>
-            <a:endParaRPr sz="1200" dirty="0">
-              <a:solidFill>
-                <a:srgbClr val="1B5E20"/>
-              </a:solidFill>
-              <a:highlight>
-                <a:srgbClr val="E8F5E9"/>
-              </a:highlight>
-              <a:latin typeface="Roboto"/>
-              <a:ea typeface="Roboto"/>
-              <a:cs typeface="Roboto"/>
-              <a:sym typeface="Roboto"/>
-            </a:endParaRPr>
-          </a:p>
-          <a:p>
-            <a:pPr marL="457200" lvl="0" indent="-304800" algn="l" rtl="0">
-              <a:lnSpc>
-                <a:spcPct val="115000"/>
-              </a:lnSpc>
-              <a:spcBef>
-                <a:spcPts val="0"/>
-              </a:spcBef>
-              <a:spcAft>
-                <a:spcPts val="0"/>
-              </a:spcAft>
-              <a:buClr>
-                <a:srgbClr val="424242"/>
-              </a:buClr>
-              <a:buSzPts val="1200"/>
-              <a:buFont typeface="Roboto"/>
-              <a:buAutoNum type="arabicPeriod"/>
-            </a:pPr>
-            <a:r>
-              <a:rPr lang="en-US" sz="1200" dirty="0">
-                <a:solidFill>
-                  <a:srgbClr val="424242"/>
-                </a:solidFill>
-                <a:latin typeface="Roboto"/>
-                <a:ea typeface="Roboto"/>
-                <a:cs typeface="Roboto"/>
-                <a:sym typeface="Roboto"/>
-              </a:rPr>
-              <a:t>Do make sure people have enough time to read through the slide before you move on,</a:t>
-            </a:r>
-            <a:endParaRPr sz="1200" dirty="0">
-              <a:solidFill>
-                <a:srgbClr val="424242"/>
-              </a:solidFill>
-              <a:latin typeface="Roboto"/>
-              <a:ea typeface="Roboto"/>
-              <a:cs typeface="Roboto"/>
-              <a:sym typeface="Roboto"/>
-            </a:endParaRPr>
-          </a:p>
-          <a:p>
-            <a:pPr marL="457200" lvl="0" indent="-304800" algn="l" rtl="0">
-              <a:lnSpc>
-                <a:spcPct val="115000"/>
-              </a:lnSpc>
-              <a:spcBef>
-                <a:spcPts val="0"/>
-              </a:spcBef>
-              <a:spcAft>
-                <a:spcPts val="0"/>
-              </a:spcAft>
-              <a:buClr>
-                <a:srgbClr val="424242"/>
-              </a:buClr>
-              <a:buSzPts val="1200"/>
-              <a:buFont typeface="Roboto"/>
-              <a:buAutoNum type="arabicPeriod"/>
-            </a:pPr>
-            <a:r>
-              <a:rPr lang="en-US" sz="1200" dirty="0">
-                <a:solidFill>
-                  <a:srgbClr val="424242"/>
-                </a:solidFill>
-                <a:latin typeface="Roboto"/>
-                <a:ea typeface="Roboto"/>
-                <a:cs typeface="Roboto"/>
-                <a:sym typeface="Roboto"/>
-              </a:rPr>
-              <a:t>Do give a high-level summary of what’s covered in the Note Well: “IETF policies on conduct, privacy and IPR.”,</a:t>
-            </a:r>
-            <a:endParaRPr sz="1200" dirty="0">
-              <a:solidFill>
-                <a:srgbClr val="424242"/>
-              </a:solidFill>
-              <a:latin typeface="Roboto"/>
-              <a:ea typeface="Roboto"/>
-              <a:cs typeface="Roboto"/>
-              <a:sym typeface="Roboto"/>
-            </a:endParaRPr>
-          </a:p>
-          <a:p>
-            <a:pPr marL="457200" lvl="0" indent="-304800" algn="l" rtl="0">
-              <a:lnSpc>
-                <a:spcPct val="115000"/>
-              </a:lnSpc>
-              <a:spcBef>
-                <a:spcPts val="0"/>
-              </a:spcBef>
-              <a:spcAft>
-                <a:spcPts val="0"/>
-              </a:spcAft>
-              <a:buClr>
-                <a:srgbClr val="424242"/>
-              </a:buClr>
-              <a:buSzPts val="1200"/>
-              <a:buFont typeface="Roboto"/>
-              <a:buAutoNum type="arabicPeriod"/>
-            </a:pPr>
-            <a:r>
-              <a:rPr lang="en-US" sz="1200" dirty="0">
-                <a:solidFill>
-                  <a:srgbClr val="424242"/>
-                </a:solidFill>
-                <a:latin typeface="Roboto"/>
-                <a:ea typeface="Roboto"/>
-                <a:cs typeface="Roboto"/>
-                <a:sym typeface="Roboto"/>
-              </a:rPr>
-              <a:t>Do encourage people to read through all the linked policies &amp; documents in detail before participating or contributing,</a:t>
-            </a:r>
-            <a:endParaRPr sz="1200" dirty="0">
-              <a:solidFill>
-                <a:srgbClr val="424242"/>
-              </a:solidFill>
-              <a:latin typeface="Roboto"/>
-              <a:ea typeface="Roboto"/>
-              <a:cs typeface="Roboto"/>
-              <a:sym typeface="Roboto"/>
-            </a:endParaRPr>
-          </a:p>
-          <a:p>
-            <a:pPr marL="457200" lvl="0" indent="-304800" algn="l" rtl="0">
-              <a:lnSpc>
-                <a:spcPct val="115000"/>
-              </a:lnSpc>
-              <a:spcBef>
-                <a:spcPts val="0"/>
-              </a:spcBef>
-              <a:spcAft>
-                <a:spcPts val="0"/>
-              </a:spcAft>
-              <a:buClr>
-                <a:srgbClr val="424242"/>
-              </a:buClr>
-              <a:buSzPts val="1200"/>
-              <a:buFont typeface="Roboto"/>
-              <a:buAutoNum type="arabicPeriod"/>
-            </a:pPr>
-            <a:r>
-              <a:rPr lang="en-US" sz="1200" dirty="0">
-                <a:solidFill>
-                  <a:srgbClr val="424242"/>
-                </a:solidFill>
-                <a:latin typeface="Roboto"/>
-                <a:ea typeface="Roboto"/>
-                <a:cs typeface="Roboto"/>
-                <a:sym typeface="Roboto"/>
-              </a:rPr>
-              <a:t>Do explain where people can direct questions or concerns (IETF Executive Director or </a:t>
-            </a:r>
-            <a:r>
-              <a:rPr lang="en-US" sz="1200" dirty="0" err="1">
-                <a:solidFill>
-                  <a:srgbClr val="424242"/>
-                </a:solidFill>
-                <a:latin typeface="Roboto"/>
-                <a:ea typeface="Roboto"/>
-                <a:cs typeface="Roboto"/>
-                <a:sym typeface="Roboto"/>
-              </a:rPr>
-              <a:t>Ombudsteam</a:t>
-            </a:r>
-            <a:r>
-              <a:rPr lang="en-US" sz="1200" dirty="0">
-                <a:solidFill>
-                  <a:srgbClr val="424242"/>
-                </a:solidFill>
-                <a:latin typeface="Roboto"/>
-                <a:ea typeface="Roboto"/>
-                <a:cs typeface="Roboto"/>
-                <a:sym typeface="Roboto"/>
-              </a:rPr>
-              <a:t>).</a:t>
-            </a:r>
-            <a:endParaRPr sz="1200" dirty="0">
-              <a:solidFill>
-                <a:srgbClr val="424242"/>
-              </a:solidFill>
-              <a:latin typeface="Roboto"/>
-              <a:ea typeface="Roboto"/>
-              <a:cs typeface="Roboto"/>
-              <a:sym typeface="Roboto"/>
-            </a:endParaRPr>
-          </a:p>
-          <a:p>
-            <a:pPr marL="0" lvl="0" indent="0" algn="l" rtl="0">
-              <a:lnSpc>
-                <a:spcPct val="115000"/>
-              </a:lnSpc>
-              <a:spcBef>
-                <a:spcPts val="0"/>
-              </a:spcBef>
-              <a:spcAft>
-                <a:spcPts val="0"/>
-              </a:spcAft>
-              <a:buClr>
-                <a:schemeClr val="dk1"/>
-              </a:buClr>
-              <a:buSzPts val="1100"/>
-              <a:buFont typeface="Arial"/>
-              <a:buNone/>
-            </a:pPr>
-            <a:r>
-              <a:rPr lang="en-US" sz="1200" dirty="0">
-                <a:solidFill>
-                  <a:srgbClr val="B33F00"/>
-                </a:solidFill>
-                <a:highlight>
-                  <a:srgbClr val="FFF3E0"/>
-                </a:highlight>
-                <a:latin typeface="Roboto"/>
-                <a:ea typeface="Roboto"/>
-                <a:cs typeface="Roboto"/>
-                <a:sym typeface="Roboto"/>
-              </a:rPr>
-              <a:t>DON'T</a:t>
-            </a:r>
-            <a:endParaRPr sz="1200" dirty="0">
-              <a:solidFill>
-                <a:srgbClr val="B33F00"/>
-              </a:solidFill>
-              <a:highlight>
-                <a:srgbClr val="FFF3E0"/>
-              </a:highlight>
-              <a:latin typeface="Roboto"/>
-              <a:ea typeface="Roboto"/>
-              <a:cs typeface="Roboto"/>
-              <a:sym typeface="Roboto"/>
-            </a:endParaRPr>
-          </a:p>
-          <a:p>
-            <a:pPr marL="457200" lvl="0" indent="-304800" algn="l" rtl="0">
-              <a:lnSpc>
-                <a:spcPct val="115000"/>
-              </a:lnSpc>
-              <a:spcBef>
-                <a:spcPts val="0"/>
-              </a:spcBef>
-              <a:spcAft>
-                <a:spcPts val="0"/>
-              </a:spcAft>
-              <a:buClr>
-                <a:srgbClr val="424242"/>
-              </a:buClr>
-              <a:buSzPts val="1200"/>
-              <a:buFont typeface="Roboto"/>
-              <a:buAutoNum type="arabicPeriod"/>
-            </a:pPr>
-            <a:r>
-              <a:rPr lang="en-US" sz="1200" dirty="0">
-                <a:solidFill>
-                  <a:srgbClr val="424242"/>
-                </a:solidFill>
-                <a:latin typeface="Roboto"/>
-                <a:ea typeface="Roboto"/>
-                <a:cs typeface="Roboto"/>
-                <a:sym typeface="Roboto"/>
-              </a:rPr>
-              <a:t>Don’t dismiss the importance or relevance of any of the information on the Note Well.</a:t>
-            </a:r>
-            <a:endParaRPr sz="1200" dirty="0">
-              <a:solidFill>
-                <a:srgbClr val="424242"/>
-              </a:solidFill>
-              <a:latin typeface="Roboto"/>
-              <a:ea typeface="Roboto"/>
-              <a:cs typeface="Roboto"/>
-              <a:sym typeface="Roboto"/>
-            </a:endParaRPr>
-          </a:p>
-          <a:p>
-            <a:pPr marL="457200" lvl="0" indent="-304800" algn="l" rtl="0">
-              <a:lnSpc>
-                <a:spcPct val="115000"/>
-              </a:lnSpc>
-              <a:spcBef>
-                <a:spcPts val="0"/>
-              </a:spcBef>
-              <a:spcAft>
-                <a:spcPts val="0"/>
-              </a:spcAft>
-              <a:buClr>
-                <a:srgbClr val="424242"/>
-              </a:buClr>
-              <a:buSzPts val="1200"/>
-              <a:buFont typeface="Roboto"/>
-              <a:buAutoNum type="arabicPeriod"/>
-            </a:pPr>
-            <a:r>
-              <a:rPr lang="en-US" sz="1200" dirty="0">
-                <a:solidFill>
-                  <a:srgbClr val="424242"/>
-                </a:solidFill>
-                <a:latin typeface="Roboto"/>
-                <a:ea typeface="Roboto"/>
-                <a:cs typeface="Roboto"/>
-                <a:sym typeface="Roboto"/>
-              </a:rPr>
-              <a:t>Don’t interpret the meaning or get into the substance of any of the topics or content of the policies.</a:t>
-            </a:r>
-            <a:endParaRPr sz="1200" dirty="0">
-              <a:solidFill>
-                <a:srgbClr val="424242"/>
-              </a:solidFill>
-              <a:latin typeface="Roboto"/>
-              <a:ea typeface="Roboto"/>
-              <a:cs typeface="Roboto"/>
-              <a:sym typeface="Roboto"/>
-            </a:endParaRPr>
-          </a:p>
-          <a:p>
-            <a:pPr marL="457200" lvl="0" indent="-304800" algn="l" rtl="0">
-              <a:lnSpc>
-                <a:spcPct val="115000"/>
-              </a:lnSpc>
-              <a:spcBef>
-                <a:spcPts val="0"/>
-              </a:spcBef>
-              <a:spcAft>
-                <a:spcPts val="0"/>
-              </a:spcAft>
-              <a:buClr>
-                <a:srgbClr val="424242"/>
-              </a:buClr>
-              <a:buSzPts val="1200"/>
-              <a:buFont typeface="Roboto"/>
-              <a:buAutoNum type="arabicPeriod"/>
-            </a:pPr>
-            <a:r>
-              <a:rPr lang="en-US" sz="1200" dirty="0">
-                <a:solidFill>
-                  <a:srgbClr val="424242"/>
-                </a:solidFill>
-                <a:latin typeface="Roboto"/>
-                <a:ea typeface="Roboto"/>
-                <a:cs typeface="Roboto"/>
-                <a:sym typeface="Roboto"/>
-              </a:rPr>
-              <a:t>Don’t communicate that the Note Well conveys all the information participants need to know.</a:t>
-            </a:r>
-            <a:endParaRPr sz="1200" dirty="0">
-              <a:solidFill>
-                <a:srgbClr val="424242"/>
-              </a:solidFill>
-              <a:latin typeface="Roboto"/>
-              <a:ea typeface="Roboto"/>
-              <a:cs typeface="Roboto"/>
-              <a:sym typeface="Roboto"/>
-            </a:endParaRPr>
-          </a:p>
-          <a:p>
-            <a:pPr marL="457200" lvl="0" indent="-304800" algn="l" rtl="0">
-              <a:lnSpc>
-                <a:spcPct val="115000"/>
-              </a:lnSpc>
-              <a:spcBef>
-                <a:spcPts val="0"/>
-              </a:spcBef>
-              <a:spcAft>
-                <a:spcPts val="0"/>
-              </a:spcAft>
-              <a:buClr>
-                <a:srgbClr val="424242"/>
-              </a:buClr>
-              <a:buSzPts val="1200"/>
-              <a:buFont typeface="Roboto"/>
-              <a:buAutoNum type="arabicPeriod"/>
-            </a:pPr>
-            <a:r>
-              <a:rPr lang="en-US" sz="1200" dirty="0">
-                <a:solidFill>
-                  <a:srgbClr val="424242"/>
-                </a:solidFill>
-                <a:latin typeface="Roboto"/>
-                <a:ea typeface="Roboto"/>
-                <a:cs typeface="Roboto"/>
-                <a:sym typeface="Roboto"/>
-              </a:rPr>
-              <a:t>Don’t address questions or concerns in the meeting itself.</a:t>
-            </a:r>
-            <a:endParaRPr sz="1200" dirty="0">
-              <a:solidFill>
-                <a:srgbClr val="424242"/>
-              </a:solidFill>
-              <a:latin typeface="Roboto"/>
-              <a:ea typeface="Roboto"/>
-              <a:cs typeface="Roboto"/>
-              <a:sym typeface="Roboto"/>
-            </a:endParaRPr>
-          </a:p>
-          <a:p>
-            <a:pPr marL="0" lvl="0" indent="0" algn="l" rtl="0">
-              <a:lnSpc>
-                <a:spcPct val="115000"/>
-              </a:lnSpc>
-              <a:spcBef>
-                <a:spcPts val="0"/>
-              </a:spcBef>
-              <a:spcAft>
-                <a:spcPts val="0"/>
-              </a:spcAft>
-              <a:buClr>
-                <a:schemeClr val="dk1"/>
-              </a:buClr>
-              <a:buSzPts val="1100"/>
-              <a:buFont typeface="Arial"/>
-              <a:buNone/>
-            </a:pPr>
-            <a:endParaRPr sz="1200" dirty="0">
-              <a:solidFill>
-                <a:srgbClr val="424242"/>
-              </a:solidFill>
-              <a:latin typeface="Roboto"/>
-              <a:ea typeface="Roboto"/>
-              <a:cs typeface="Roboto"/>
-              <a:sym typeface="Roboto"/>
-            </a:endParaRPr>
-          </a:p>
           <a:p>
             <a:pPr marL="0" lvl="0" indent="0" algn="l" rtl="0">
               <a:spcBef>
@@ -11241,8 +10515,8 @@
           </a:prstGeom>
         </p:spPr>
       </p:pic>
-      <mc:AlternateContent xmlns:mc="http://schemas.openxmlformats.org/markup-compatibility/2006">
-        <mc:Choice xmlns:p14="http://schemas.microsoft.com/office/powerpoint/2010/main" Requires="p14">
+      <mc:AlternateContent xmlns:mc="http://schemas.openxmlformats.org/markup-compatibility/2006" xmlns:p14="http://schemas.microsoft.com/office/powerpoint/2010/main">
+        <mc:Choice Requires="p14">
           <p:contentPart p14:bwMode="auto" r:id="rId4">
             <p14:nvContentPartPr>
               <p14:cNvPr id="4" name="Ink 3">
@@ -11261,7 +10535,7 @@
             </p14:xfrm>
           </p:contentPart>
         </mc:Choice>
-        <mc:Fallback>
+        <mc:Fallback xmlns="">
           <p:pic>
             <p:nvPicPr>
               <p:cNvPr id="4" name="Ink 3">
@@ -11302,138 +10576,18 @@
   <p:clrMapOvr>
     <a:masterClrMapping/>
   </p:clrMapOvr>
-  <mc:AlternateContent xmlns:mc="http://schemas.openxmlformats.org/markup-compatibility/2006">
-    <mc:Choice xmlns:p14="http://schemas.microsoft.com/office/powerpoint/2010/main" Requires="p14">
+  <mc:AlternateContent xmlns:mc="http://schemas.openxmlformats.org/markup-compatibility/2006" xmlns:p14="http://schemas.microsoft.com/office/powerpoint/2010/main">
+    <mc:Choice Requires="p14">
       <p:transition spd="med" p14:dur="700">
         <p:fade/>
       </p:transition>
     </mc:Choice>
-    <mc:Fallback>
+    <mc:Fallback xmlns="">
       <p:transition spd="med">
         <p:fade/>
       </p:transition>
     </mc:Fallback>
   </mc:AlternateContent>
-  <p:timing>
-    <p:tnLst>
-      <p:par>
-        <p:cTn id="1" dur="indefinite" restart="never" nodeType="tmRoot">
-          <p:childTnLst>
-            <p:seq concurrent="1" nextAc="seek">
-              <p:cTn id="2" dur="indefinite" nodeType="mainSeq">
-                <p:childTnLst>
-                  <p:par>
-                    <p:cTn id="3" fill="hold">
-                      <p:stCondLst>
-                        <p:cond delay="indefinite"/>
-                      </p:stCondLst>
-                      <p:childTnLst>
-                        <p:par>
-                          <p:cTn id="4" fill="hold">
-                            <p:stCondLst>
-                              <p:cond delay="0"/>
-                            </p:stCondLst>
-                            <p:childTnLst>
-                              <p:par>
-                                <p:cTn id="5" presetID="1" presetClass="entr" presetSubtype="0" fill="hold" nodeType="clickEffect">
-                                  <p:stCondLst>
-                                    <p:cond delay="0"/>
-                                  </p:stCondLst>
-                                  <p:childTnLst>
-                                    <p:set>
-                                      <p:cBhvr>
-                                        <p:cTn id="6" dur="1" fill="hold">
-                                          <p:stCondLst>
-                                            <p:cond delay="0"/>
-                                          </p:stCondLst>
-                                        </p:cTn>
-                                        <p:tgtEl>
-                                          <p:spTgt spid="3"/>
-                                        </p:tgtEl>
-                                        <p:attrNameLst>
-                                          <p:attrName>style.visibility</p:attrName>
-                                        </p:attrNameLst>
-                                      </p:cBhvr>
-                                      <p:to>
-                                        <p:strVal val="visible"/>
-                                      </p:to>
-                                    </p:set>
-                                  </p:childTnLst>
-                                </p:cTn>
-                              </p:par>
-                            </p:childTnLst>
-                          </p:cTn>
-                        </p:par>
-                      </p:childTnLst>
-                    </p:cTn>
-                  </p:par>
-                  <p:par>
-                    <p:cTn id="7" fill="hold">
-                      <p:stCondLst>
-                        <p:cond delay="indefinite"/>
-                      </p:stCondLst>
-                      <p:childTnLst>
-                        <p:par>
-                          <p:cTn id="8" fill="hold">
-                            <p:stCondLst>
-                              <p:cond delay="0"/>
-                            </p:stCondLst>
-                            <p:childTnLst>
-                              <p:par>
-                                <p:cTn id="9" presetID="1" presetClass="entr" presetSubtype="0" fill="hold" nodeType="clickEffect">
-                                  <p:stCondLst>
-                                    <p:cond delay="0"/>
-                                  </p:stCondLst>
-                                  <p:childTnLst>
-                                    <p:set>
-                                      <p:cBhvr>
-                                        <p:cTn id="10" dur="1" fill="hold">
-                                          <p:stCondLst>
-                                            <p:cond delay="0"/>
-                                          </p:stCondLst>
-                                        </p:cTn>
-                                        <p:tgtEl>
-                                          <p:spTgt spid="4"/>
-                                        </p:tgtEl>
-                                        <p:attrNameLst>
-                                          <p:attrName>style.visibility</p:attrName>
-                                        </p:attrNameLst>
-                                      </p:cBhvr>
-                                      <p:to>
-                                        <p:strVal val="visible"/>
-                                      </p:to>
-                                    </p:set>
-                                  </p:childTnLst>
-                                </p:cTn>
-                              </p:par>
-                            </p:childTnLst>
-                          </p:cTn>
-                        </p:par>
-                      </p:childTnLst>
-                    </p:cTn>
-                  </p:par>
-                </p:childTnLst>
-              </p:cTn>
-              <p:prevCondLst>
-                <p:cond evt="onPrev" delay="0">
-                  <p:tgtEl>
-                    <p:sldTgt/>
-                  </p:tgtEl>
-                </p:cond>
-              </p:prevCondLst>
-              <p:nextCondLst>
-                <p:cond evt="onNext" delay="0">
-                  <p:tgtEl>
-                    <p:sldTgt/>
-                  </p:tgtEl>
-                </p:cond>
-              </p:nextCondLst>
-            </p:seq>
-          </p:childTnLst>
-        </p:cTn>
-      </p:par>
-    </p:tnLst>
-  </p:timing>
 </p:sld>
 </file>
 
@@ -11559,8 +10713,8 @@
           </a:prstGeom>
         </p:spPr>
       </p:pic>
-      <mc:AlternateContent xmlns:mc="http://schemas.openxmlformats.org/markup-compatibility/2006">
-        <mc:Choice xmlns:p14="http://schemas.microsoft.com/office/powerpoint/2010/main" Requires="p14">
+      <mc:AlternateContent xmlns:mc="http://schemas.openxmlformats.org/markup-compatibility/2006" xmlns:p14="http://schemas.microsoft.com/office/powerpoint/2010/main">
+        <mc:Choice Requires="p14">
           <p:contentPart p14:bwMode="auto" r:id="rId4">
             <p14:nvContentPartPr>
               <p14:cNvPr id="2" name="Ink 1">
@@ -11579,7 +10733,7 @@
             </p14:xfrm>
           </p:contentPart>
         </mc:Choice>
-        <mc:Fallback>
+        <mc:Fallback xmlns="">
           <p:pic>
             <p:nvPicPr>
               <p:cNvPr id="2" name="Ink 1">
@@ -11610,8 +10764,8 @@
           </p:pic>
         </mc:Fallback>
       </mc:AlternateContent>
-      <mc:AlternateContent xmlns:mc="http://schemas.openxmlformats.org/markup-compatibility/2006">
-        <mc:Choice xmlns:p14="http://schemas.microsoft.com/office/powerpoint/2010/main" Requires="p14">
+      <mc:AlternateContent xmlns:mc="http://schemas.openxmlformats.org/markup-compatibility/2006" xmlns:p14="http://schemas.microsoft.com/office/powerpoint/2010/main">
+        <mc:Choice Requires="p14">
           <p:contentPart p14:bwMode="auto" r:id="rId6">
             <p14:nvContentPartPr>
               <p14:cNvPr id="4" name="Ink 3">
@@ -11630,7 +10784,7 @@
             </p14:xfrm>
           </p:contentPart>
         </mc:Choice>
-        <mc:Fallback>
+        <mc:Fallback xmlns="">
           <p:pic>
             <p:nvPicPr>
               <p:cNvPr id="4" name="Ink 3">
@@ -11661,8 +10815,8 @@
           </p:pic>
         </mc:Fallback>
       </mc:AlternateContent>
-      <mc:AlternateContent xmlns:mc="http://schemas.openxmlformats.org/markup-compatibility/2006">
-        <mc:Choice xmlns:p14="http://schemas.microsoft.com/office/powerpoint/2010/main" Requires="p14">
+      <mc:AlternateContent xmlns:mc="http://schemas.openxmlformats.org/markup-compatibility/2006" xmlns:p14="http://schemas.microsoft.com/office/powerpoint/2010/main">
+        <mc:Choice Requires="p14">
           <p:contentPart p14:bwMode="auto" r:id="rId8">
             <p14:nvContentPartPr>
               <p14:cNvPr id="5" name="Ink 4">
@@ -11681,7 +10835,7 @@
             </p14:xfrm>
           </p:contentPart>
         </mc:Choice>
-        <mc:Fallback>
+        <mc:Fallback xmlns="">
           <p:pic>
             <p:nvPicPr>
               <p:cNvPr id="5" name="Ink 4">
@@ -11722,165 +10876,18 @@
   <p:clrMapOvr>
     <a:masterClrMapping/>
   </p:clrMapOvr>
-  <mc:AlternateContent xmlns:mc="http://schemas.openxmlformats.org/markup-compatibility/2006">
-    <mc:Choice xmlns:p14="http://schemas.microsoft.com/office/powerpoint/2010/main" Requires="p14">
+  <mc:AlternateContent xmlns:mc="http://schemas.openxmlformats.org/markup-compatibility/2006" xmlns:p14="http://schemas.microsoft.com/office/powerpoint/2010/main">
+    <mc:Choice Requires="p14">
       <p:transition spd="med" p14:dur="700">
         <p:fade/>
       </p:transition>
     </mc:Choice>
-    <mc:Fallback>
+    <mc:Fallback xmlns="">
       <p:transition spd="med">
         <p:fade/>
       </p:transition>
     </mc:Fallback>
   </mc:AlternateContent>
-  <p:timing>
-    <p:tnLst>
-      <p:par>
-        <p:cTn id="1" dur="indefinite" restart="never" nodeType="tmRoot">
-          <p:childTnLst>
-            <p:seq concurrent="1" nextAc="seek">
-              <p:cTn id="2" dur="indefinite" nodeType="mainSeq">
-                <p:childTnLst>
-                  <p:par>
-                    <p:cTn id="3" fill="hold">
-                      <p:stCondLst>
-                        <p:cond delay="indefinite"/>
-                      </p:stCondLst>
-                      <p:childTnLst>
-                        <p:par>
-                          <p:cTn id="4" fill="hold">
-                            <p:stCondLst>
-                              <p:cond delay="0"/>
-                            </p:stCondLst>
-                            <p:childTnLst>
-                              <p:par>
-                                <p:cTn id="5" presetID="1" presetClass="entr" presetSubtype="0" fill="hold" nodeType="clickEffect">
-                                  <p:stCondLst>
-                                    <p:cond delay="0"/>
-                                  </p:stCondLst>
-                                  <p:childTnLst>
-                                    <p:set>
-                                      <p:cBhvr>
-                                        <p:cTn id="6" dur="1" fill="hold">
-                                          <p:stCondLst>
-                                            <p:cond delay="0"/>
-                                          </p:stCondLst>
-                                        </p:cTn>
-                                        <p:tgtEl>
-                                          <p:spTgt spid="3"/>
-                                        </p:tgtEl>
-                                        <p:attrNameLst>
-                                          <p:attrName>style.visibility</p:attrName>
-                                        </p:attrNameLst>
-                                      </p:cBhvr>
-                                      <p:to>
-                                        <p:strVal val="visible"/>
-                                      </p:to>
-                                    </p:set>
-                                  </p:childTnLst>
-                                </p:cTn>
-                              </p:par>
-                            </p:childTnLst>
-                          </p:cTn>
-                        </p:par>
-                      </p:childTnLst>
-                    </p:cTn>
-                  </p:par>
-                  <p:par>
-                    <p:cTn id="7" fill="hold">
-                      <p:stCondLst>
-                        <p:cond delay="indefinite"/>
-                      </p:stCondLst>
-                      <p:childTnLst>
-                        <p:par>
-                          <p:cTn id="8" fill="hold">
-                            <p:stCondLst>
-                              <p:cond delay="0"/>
-                            </p:stCondLst>
-                            <p:childTnLst>
-                              <p:par>
-                                <p:cTn id="9" presetID="1" presetClass="entr" presetSubtype="0" fill="hold" nodeType="clickEffect">
-                                  <p:stCondLst>
-                                    <p:cond delay="0"/>
-                                  </p:stCondLst>
-                                  <p:childTnLst>
-                                    <p:set>
-                                      <p:cBhvr>
-                                        <p:cTn id="10" dur="1" fill="hold">
-                                          <p:stCondLst>
-                                            <p:cond delay="0"/>
-                                          </p:stCondLst>
-                                        </p:cTn>
-                                        <p:tgtEl>
-                                          <p:spTgt spid="2"/>
-                                        </p:tgtEl>
-                                        <p:attrNameLst>
-                                          <p:attrName>style.visibility</p:attrName>
-                                        </p:attrNameLst>
-                                      </p:cBhvr>
-                                      <p:to>
-                                        <p:strVal val="visible"/>
-                                      </p:to>
-                                    </p:set>
-                                  </p:childTnLst>
-                                </p:cTn>
-                              </p:par>
-                              <p:par>
-                                <p:cTn id="11" presetID="1" presetClass="entr" presetSubtype="0" fill="hold" nodeType="withEffect">
-                                  <p:stCondLst>
-                                    <p:cond delay="0"/>
-                                  </p:stCondLst>
-                                  <p:childTnLst>
-                                    <p:set>
-                                      <p:cBhvr>
-                                        <p:cTn id="12" dur="1" fill="hold">
-                                          <p:stCondLst>
-                                            <p:cond delay="0"/>
-                                          </p:stCondLst>
-                                        </p:cTn>
-                                        <p:tgtEl>
-                                          <p:spTgt spid="4"/>
-                                        </p:tgtEl>
-                                        <p:attrNameLst>
-                                          <p:attrName>style.visibility</p:attrName>
-                                        </p:attrNameLst>
-                                      </p:cBhvr>
-                                      <p:to>
-                                        <p:strVal val="visible"/>
-                                      </p:to>
-                                    </p:set>
-                                  </p:childTnLst>
-                                </p:cTn>
-                              </p:par>
-                            </p:childTnLst>
-                          </p:cTn>
-                        </p:par>
-                      </p:childTnLst>
-                    </p:cTn>
-                  </p:par>
-                </p:childTnLst>
-              </p:cTn>
-              <p:prevCondLst>
-                <p:cond evt="onPrev" delay="0">
-                  <p:tgtEl>
-                    <p:sldTgt/>
-                  </p:tgtEl>
-                </p:cond>
-              </p:prevCondLst>
-              <p:nextCondLst>
-                <p:cond evt="onNext" delay="0">
-                  <p:tgtEl>
-                    <p:sldTgt/>
-                  </p:tgtEl>
-                </p:cond>
-              </p:nextCondLst>
-            </p:seq>
-          </p:childTnLst>
-        </p:cTn>
-      </p:par>
-    </p:tnLst>
-  </p:timing>
 </p:sld>
 </file>
 
@@ -12006,8 +11013,8 @@
           </a:prstGeom>
         </p:spPr>
       </p:pic>
-      <mc:AlternateContent xmlns:mc="http://schemas.openxmlformats.org/markup-compatibility/2006">
-        <mc:Choice xmlns:p14="http://schemas.microsoft.com/office/powerpoint/2010/main" Requires="p14">
+      <mc:AlternateContent xmlns:mc="http://schemas.openxmlformats.org/markup-compatibility/2006" xmlns:p14="http://schemas.microsoft.com/office/powerpoint/2010/main">
+        <mc:Choice Requires="p14">
           <p:contentPart p14:bwMode="auto" r:id="rId4">
             <p14:nvContentPartPr>
               <p14:cNvPr id="4" name="Ink 3">
@@ -12026,7 +11033,7 @@
             </p14:xfrm>
           </p:contentPart>
         </mc:Choice>
-        <mc:Fallback>
+        <mc:Fallback xmlns="">
           <p:pic>
             <p:nvPicPr>
               <p:cNvPr id="4" name="Ink 3">
@@ -12067,138 +11074,18 @@
   <p:clrMapOvr>
     <a:masterClrMapping/>
   </p:clrMapOvr>
-  <mc:AlternateContent xmlns:mc="http://schemas.openxmlformats.org/markup-compatibility/2006">
-    <mc:Choice xmlns:p14="http://schemas.microsoft.com/office/powerpoint/2010/main" Requires="p14">
+  <mc:AlternateContent xmlns:mc="http://schemas.openxmlformats.org/markup-compatibility/2006" xmlns:p14="http://schemas.microsoft.com/office/powerpoint/2010/main">
+    <mc:Choice Requires="p14">
       <p:transition spd="med" p14:dur="700">
         <p:fade/>
       </p:transition>
     </mc:Choice>
-    <mc:Fallback>
+    <mc:Fallback xmlns="">
       <p:transition spd="med">
         <p:fade/>
       </p:transition>
     </mc:Fallback>
   </mc:AlternateContent>
-  <p:timing>
-    <p:tnLst>
-      <p:par>
-        <p:cTn id="1" dur="indefinite" restart="never" nodeType="tmRoot">
-          <p:childTnLst>
-            <p:seq concurrent="1" nextAc="seek">
-              <p:cTn id="2" dur="indefinite" nodeType="mainSeq">
-                <p:childTnLst>
-                  <p:par>
-                    <p:cTn id="3" fill="hold">
-                      <p:stCondLst>
-                        <p:cond delay="indefinite"/>
-                      </p:stCondLst>
-                      <p:childTnLst>
-                        <p:par>
-                          <p:cTn id="4" fill="hold">
-                            <p:stCondLst>
-                              <p:cond delay="0"/>
-                            </p:stCondLst>
-                            <p:childTnLst>
-                              <p:par>
-                                <p:cTn id="5" presetID="1" presetClass="entr" presetSubtype="0" fill="hold" nodeType="clickEffect">
-                                  <p:stCondLst>
-                                    <p:cond delay="0"/>
-                                  </p:stCondLst>
-                                  <p:childTnLst>
-                                    <p:set>
-                                      <p:cBhvr>
-                                        <p:cTn id="6" dur="1" fill="hold">
-                                          <p:stCondLst>
-                                            <p:cond delay="0"/>
-                                          </p:stCondLst>
-                                        </p:cTn>
-                                        <p:tgtEl>
-                                          <p:spTgt spid="3"/>
-                                        </p:tgtEl>
-                                        <p:attrNameLst>
-                                          <p:attrName>style.visibility</p:attrName>
-                                        </p:attrNameLst>
-                                      </p:cBhvr>
-                                      <p:to>
-                                        <p:strVal val="visible"/>
-                                      </p:to>
-                                    </p:set>
-                                  </p:childTnLst>
-                                </p:cTn>
-                              </p:par>
-                            </p:childTnLst>
-                          </p:cTn>
-                        </p:par>
-                      </p:childTnLst>
-                    </p:cTn>
-                  </p:par>
-                  <p:par>
-                    <p:cTn id="7" fill="hold">
-                      <p:stCondLst>
-                        <p:cond delay="indefinite"/>
-                      </p:stCondLst>
-                      <p:childTnLst>
-                        <p:par>
-                          <p:cTn id="8" fill="hold">
-                            <p:stCondLst>
-                              <p:cond delay="0"/>
-                            </p:stCondLst>
-                            <p:childTnLst>
-                              <p:par>
-                                <p:cTn id="9" presetID="1" presetClass="entr" presetSubtype="0" fill="hold" nodeType="clickEffect">
-                                  <p:stCondLst>
-                                    <p:cond delay="0"/>
-                                  </p:stCondLst>
-                                  <p:childTnLst>
-                                    <p:set>
-                                      <p:cBhvr>
-                                        <p:cTn id="10" dur="1" fill="hold">
-                                          <p:stCondLst>
-                                            <p:cond delay="0"/>
-                                          </p:stCondLst>
-                                        </p:cTn>
-                                        <p:tgtEl>
-                                          <p:spTgt spid="4"/>
-                                        </p:tgtEl>
-                                        <p:attrNameLst>
-                                          <p:attrName>style.visibility</p:attrName>
-                                        </p:attrNameLst>
-                                      </p:cBhvr>
-                                      <p:to>
-                                        <p:strVal val="visible"/>
-                                      </p:to>
-                                    </p:set>
-                                  </p:childTnLst>
-                                </p:cTn>
-                              </p:par>
-                            </p:childTnLst>
-                          </p:cTn>
-                        </p:par>
-                      </p:childTnLst>
-                    </p:cTn>
-                  </p:par>
-                </p:childTnLst>
-              </p:cTn>
-              <p:prevCondLst>
-                <p:cond evt="onPrev" delay="0">
-                  <p:tgtEl>
-                    <p:sldTgt/>
-                  </p:tgtEl>
-                </p:cond>
-              </p:prevCondLst>
-              <p:nextCondLst>
-                <p:cond evt="onNext" delay="0">
-                  <p:tgtEl>
-                    <p:sldTgt/>
-                  </p:tgtEl>
-                </p:cond>
-              </p:nextCondLst>
-            </p:seq>
-          </p:childTnLst>
-        </p:cTn>
-      </p:par>
-    </p:tnLst>
-  </p:timing>
 </p:sld>
 </file>
 
@@ -12328,13 +11215,8 @@
           <a:p>
             <a:r>
               <a:rPr lang="en-CA" dirty="0"/>
-              <a:t>More work to do on Binary YANG Push (e.g. SID </a:t>
+              <a:t>More work to do on Binary YANG Push (e.g. SID file management)</a:t>
             </a:r>
-            <a:r>
-              <a:rPr lang="en-CA"/>
-              <a:t>file management)</a:t>
-            </a:r>
-            <a:endParaRPr lang="en-CA" dirty="0"/>
           </a:p>
           <a:p>
             <a:r>
@@ -12365,13 +11247,13 @@
   <p:clrMapOvr>
     <a:masterClrMapping/>
   </p:clrMapOvr>
-  <mc:AlternateContent xmlns:mc="http://schemas.openxmlformats.org/markup-compatibility/2006">
-    <mc:Choice xmlns:p14="http://schemas.microsoft.com/office/powerpoint/2010/main" Requires="p14">
+  <mc:AlternateContent xmlns:mc="http://schemas.openxmlformats.org/markup-compatibility/2006" xmlns:p14="http://schemas.microsoft.com/office/powerpoint/2010/main">
+    <mc:Choice Requires="p14">
       <p:transition spd="med" p14:dur="700">
         <p:fade/>
       </p:transition>
     </mc:Choice>
-    <mc:Fallback>
+    <mc:Fallback xmlns="">
       <p:transition spd="med">
         <p:fade/>
       </p:transition>
@@ -13452,7 +12334,7 @@
         <p:fade/>
       </p:transition>
     </mc:Choice>
-    <mc:Fallback xmlns:ahyp="http://schemas.microsoft.com/office/drawing/2018/hyperlinkcolor" xmlns:p15="http://schemas.microsoft.com/office/powerpoint/2012/main" xmlns:com="http://schemas.openxmlformats.org/drawingml/2006/compatibility" xmlns:pvml="urn:schemas-microsoft-com:office:powerpoint" xmlns:v="urn:schemas-microsoft-com:vml" xmlns:o="urn:schemas-microsoft-com:office:office" xmlns:dgm="http://schemas.openxmlformats.org/drawingml/2006/diagram" xmlns:c="http://schemas.openxmlformats.org/drawingml/2006/chart" xmlns:mv="urn:schemas-microsoft-com:mac:vml" xmlns="">
+    <mc:Fallback xmlns="" xmlns:mv="urn:schemas-microsoft-com:mac:vml" xmlns:c="http://schemas.openxmlformats.org/drawingml/2006/chart" xmlns:dgm="http://schemas.openxmlformats.org/drawingml/2006/diagram" xmlns:o="urn:schemas-microsoft-com:office:office" xmlns:v="urn:schemas-microsoft-com:vml" xmlns:pvml="urn:schemas-microsoft-com:office:powerpoint" xmlns:com="http://schemas.openxmlformats.org/drawingml/2006/compatibility" xmlns:p15="http://schemas.microsoft.com/office/powerpoint/2012/main" xmlns:ahyp="http://schemas.microsoft.com/office/drawing/2018/hyperlinkcolor">
       <p:transition spd="slow">
         <p:fade/>
       </p:transition>
@@ -14654,7 +13536,7 @@
         <p:fade/>
       </p:transition>
     </mc:Choice>
-    <mc:Fallback xmlns:ahyp="http://schemas.microsoft.com/office/drawing/2018/hyperlinkcolor" xmlns:p15="http://schemas.microsoft.com/office/powerpoint/2012/main" xmlns:com="http://schemas.openxmlformats.org/drawingml/2006/compatibility" xmlns:pvml="urn:schemas-microsoft-com:office:powerpoint" xmlns:v="urn:schemas-microsoft-com:vml" xmlns:o="urn:schemas-microsoft-com:office:office" xmlns:dgm="http://schemas.openxmlformats.org/drawingml/2006/diagram" xmlns:c="http://schemas.openxmlformats.org/drawingml/2006/chart" xmlns:mv="urn:schemas-microsoft-com:mac:vml" xmlns="">
+    <mc:Fallback xmlns="" xmlns:mv="urn:schemas-microsoft-com:mac:vml" xmlns:c="http://schemas.openxmlformats.org/drawingml/2006/chart" xmlns:dgm="http://schemas.openxmlformats.org/drawingml/2006/diagram" xmlns:o="urn:schemas-microsoft-com:office:office" xmlns:v="urn:schemas-microsoft-com:vml" xmlns:pvml="urn:schemas-microsoft-com:office:powerpoint" xmlns:com="http://schemas.openxmlformats.org/drawingml/2006/compatibility" xmlns:p15="http://schemas.microsoft.com/office/powerpoint/2012/main" xmlns:ahyp="http://schemas.microsoft.com/office/drawing/2018/hyperlinkcolor">
       <p:transition spd="slow">
         <p:fade/>
       </p:transition>
@@ -14982,13 +13864,13 @@
   <p:clrMapOvr>
     <a:masterClrMapping/>
   </p:clrMapOvr>
-  <mc:AlternateContent xmlns:mc="http://schemas.openxmlformats.org/markup-compatibility/2006">
-    <mc:Choice xmlns:p14="http://schemas.microsoft.com/office/powerpoint/2010/main" Requires="p14">
+  <mc:AlternateContent xmlns:mc="http://schemas.openxmlformats.org/markup-compatibility/2006" xmlns:p14="http://schemas.microsoft.com/office/powerpoint/2010/main">
+    <mc:Choice Requires="p14">
       <p:transition spd="med" p14:dur="700">
         <p:fade/>
       </p:transition>
     </mc:Choice>
-    <mc:Fallback>
+    <mc:Fallback xmlns="">
       <p:transition spd="med">
         <p:fade/>
       </p:transition>
@@ -15721,8 +14603,8 @@
           </a:prstGeom>
         </p:spPr>
       </p:pic>
-      <mc:AlternateContent xmlns:mc="http://schemas.openxmlformats.org/markup-compatibility/2006">
-        <mc:Choice xmlns:p14="http://schemas.microsoft.com/office/powerpoint/2010/main" Requires="p14">
+      <mc:AlternateContent xmlns:mc="http://schemas.openxmlformats.org/markup-compatibility/2006" xmlns:p14="http://schemas.microsoft.com/office/powerpoint/2010/main">
+        <mc:Choice Requires="p14">
           <p:contentPart p14:bwMode="auto" r:id="rId4">
             <p14:nvContentPartPr>
               <p14:cNvPr id="4" name="Ink 3">
@@ -15741,7 +14623,7 @@
             </p14:xfrm>
           </p:contentPart>
         </mc:Choice>
-        <mc:Fallback>
+        <mc:Fallback xmlns="">
           <p:pic>
             <p:nvPicPr>
               <p:cNvPr id="4" name="Ink 3">
@@ -15782,138 +14664,18 @@
   <p:clrMapOvr>
     <a:masterClrMapping/>
   </p:clrMapOvr>
-  <mc:AlternateContent xmlns:mc="http://schemas.openxmlformats.org/markup-compatibility/2006">
-    <mc:Choice xmlns:p14="http://schemas.microsoft.com/office/powerpoint/2010/main" Requires="p14">
+  <mc:AlternateContent xmlns:mc="http://schemas.openxmlformats.org/markup-compatibility/2006" xmlns:p14="http://schemas.microsoft.com/office/powerpoint/2010/main">
+    <mc:Choice Requires="p14">
       <p:transition spd="med" p14:dur="700">
         <p:fade/>
       </p:transition>
     </mc:Choice>
-    <mc:Fallback>
+    <mc:Fallback xmlns="">
       <p:transition spd="med">
         <p:fade/>
       </p:transition>
     </mc:Fallback>
   </mc:AlternateContent>
-  <p:timing>
-    <p:tnLst>
-      <p:par>
-        <p:cTn id="1" dur="indefinite" restart="never" nodeType="tmRoot">
-          <p:childTnLst>
-            <p:seq concurrent="1" nextAc="seek">
-              <p:cTn id="2" dur="indefinite" nodeType="mainSeq">
-                <p:childTnLst>
-                  <p:par>
-                    <p:cTn id="3" fill="hold">
-                      <p:stCondLst>
-                        <p:cond delay="indefinite"/>
-                      </p:stCondLst>
-                      <p:childTnLst>
-                        <p:par>
-                          <p:cTn id="4" fill="hold">
-                            <p:stCondLst>
-                              <p:cond delay="0"/>
-                            </p:stCondLst>
-                            <p:childTnLst>
-                              <p:par>
-                                <p:cTn id="5" presetID="1" presetClass="entr" presetSubtype="0" fill="hold" nodeType="clickEffect">
-                                  <p:stCondLst>
-                                    <p:cond delay="0"/>
-                                  </p:stCondLst>
-                                  <p:childTnLst>
-                                    <p:set>
-                                      <p:cBhvr>
-                                        <p:cTn id="6" dur="1" fill="hold">
-                                          <p:stCondLst>
-                                            <p:cond delay="0"/>
-                                          </p:stCondLst>
-                                        </p:cTn>
-                                        <p:tgtEl>
-                                          <p:spTgt spid="3"/>
-                                        </p:tgtEl>
-                                        <p:attrNameLst>
-                                          <p:attrName>style.visibility</p:attrName>
-                                        </p:attrNameLst>
-                                      </p:cBhvr>
-                                      <p:to>
-                                        <p:strVal val="visible"/>
-                                      </p:to>
-                                    </p:set>
-                                  </p:childTnLst>
-                                </p:cTn>
-                              </p:par>
-                            </p:childTnLst>
-                          </p:cTn>
-                        </p:par>
-                      </p:childTnLst>
-                    </p:cTn>
-                  </p:par>
-                  <p:par>
-                    <p:cTn id="7" fill="hold">
-                      <p:stCondLst>
-                        <p:cond delay="indefinite"/>
-                      </p:stCondLst>
-                      <p:childTnLst>
-                        <p:par>
-                          <p:cTn id="8" fill="hold">
-                            <p:stCondLst>
-                              <p:cond delay="0"/>
-                            </p:stCondLst>
-                            <p:childTnLst>
-                              <p:par>
-                                <p:cTn id="9" presetID="1" presetClass="entr" presetSubtype="0" fill="hold" nodeType="clickEffect">
-                                  <p:stCondLst>
-                                    <p:cond delay="0"/>
-                                  </p:stCondLst>
-                                  <p:childTnLst>
-                                    <p:set>
-                                      <p:cBhvr>
-                                        <p:cTn id="10" dur="1" fill="hold">
-                                          <p:stCondLst>
-                                            <p:cond delay="0"/>
-                                          </p:stCondLst>
-                                        </p:cTn>
-                                        <p:tgtEl>
-                                          <p:spTgt spid="4"/>
-                                        </p:tgtEl>
-                                        <p:attrNameLst>
-                                          <p:attrName>style.visibility</p:attrName>
-                                        </p:attrNameLst>
-                                      </p:cBhvr>
-                                      <p:to>
-                                        <p:strVal val="visible"/>
-                                      </p:to>
-                                    </p:set>
-                                  </p:childTnLst>
-                                </p:cTn>
-                              </p:par>
-                            </p:childTnLst>
-                          </p:cTn>
-                        </p:par>
-                      </p:childTnLst>
-                    </p:cTn>
-                  </p:par>
-                </p:childTnLst>
-              </p:cTn>
-              <p:prevCondLst>
-                <p:cond evt="onPrev" delay="0">
-                  <p:tgtEl>
-                    <p:sldTgt/>
-                  </p:tgtEl>
-                </p:cond>
-              </p:prevCondLst>
-              <p:nextCondLst>
-                <p:cond evt="onNext" delay="0">
-                  <p:tgtEl>
-                    <p:sldTgt/>
-                  </p:tgtEl>
-                </p:cond>
-              </p:nextCondLst>
-            </p:seq>
-          </p:childTnLst>
-        </p:cTn>
-      </p:par>
-    </p:tnLst>
-  </p:timing>
 </p:sld>
 </file>
 
@@ -16477,12 +15239,4 @@
   <a:objectDefaults/>
   <a:extraClrSchemeLst/>
 </a:theme>
-</file>
-
-<file path=docMetadata/LabelInfo.xml><?xml version="1.0" encoding="utf-8"?>
-<clbl:labelList xmlns:clbl="http://schemas.microsoft.com/office/2020/mipLabelMetadata">
-  <clbl:label id="{07222825-62ea-40f3-96b5-5375c07996e2}" enabled="1" method="Privileged" siteId="{90c7a20a-f34b-40bf-bc48-b9253b6f5d20}" removed="0"/>
-  <clbl:label id="{20bd2185-7f4f-483c-8403-3480aaa4171f}" enabled="1" method="Standard" siteId="{72adb271-2fc7-4afe-a5ee-9de6a59f6bfb}" removed="0"/>
-  <clbl:label id="{2e1fccfb-80ca-4fe1-a574-1516544edb53}" enabled="1" method="Standard" siteId="{364e5b87-c1c7-420d-9bee-c35d19b557a1}" removed="0"/>
-</clbl:labelList>
 </file>
</xml_diff>

<commit_message>
Slides for session 2 + upload pdf for both sessions
</commit_message>
<xml_diff>
--- a/126/slides/slides-126-nmop-chair-slides-session1.pptx
+++ b/126/slides/slides-126-nmop-chair-slides-session1.pptx
@@ -10209,7 +10209,7 @@
                 <a:cs typeface="Inter"/>
                 <a:sym typeface="Inter"/>
               </a:rPr>
-              <a:t>© 202 IETF Trust </a:t>
+              <a:t>© 2026 IETF Trust </a:t>
             </a:r>
             <a:endParaRPr sz="1200" dirty="0">
               <a:latin typeface="Inter"/>
@@ -12334,7 +12334,7 @@
         <p:fade/>
       </p:transition>
     </mc:Choice>
-    <mc:Fallback xmlns="" xmlns:mv="urn:schemas-microsoft-com:mac:vml" xmlns:c="http://schemas.openxmlformats.org/drawingml/2006/chart" xmlns:dgm="http://schemas.openxmlformats.org/drawingml/2006/diagram" xmlns:o="urn:schemas-microsoft-com:office:office" xmlns:v="urn:schemas-microsoft-com:vml" xmlns:pvml="urn:schemas-microsoft-com:office:powerpoint" xmlns:com="http://schemas.openxmlformats.org/drawingml/2006/compatibility" xmlns:p15="http://schemas.microsoft.com/office/powerpoint/2012/main" xmlns:ahyp="http://schemas.microsoft.com/office/drawing/2018/hyperlinkcolor">
+    <mc:Fallback xmlns:ahyp="http://schemas.microsoft.com/office/drawing/2018/hyperlinkcolor" xmlns:p15="http://schemas.microsoft.com/office/powerpoint/2012/main" xmlns:com="http://schemas.openxmlformats.org/drawingml/2006/compatibility" xmlns:pvml="urn:schemas-microsoft-com:office:powerpoint" xmlns:v="urn:schemas-microsoft-com:vml" xmlns:o="urn:schemas-microsoft-com:office:office" xmlns:dgm="http://schemas.openxmlformats.org/drawingml/2006/diagram" xmlns:c="http://schemas.openxmlformats.org/drawingml/2006/chart" xmlns:mv="urn:schemas-microsoft-com:mac:vml" xmlns="">
       <p:transition spd="slow">
         <p:fade/>
       </p:transition>
@@ -13536,7 +13536,7 @@
         <p:fade/>
       </p:transition>
     </mc:Choice>
-    <mc:Fallback xmlns="" xmlns:mv="urn:schemas-microsoft-com:mac:vml" xmlns:c="http://schemas.openxmlformats.org/drawingml/2006/chart" xmlns:dgm="http://schemas.openxmlformats.org/drawingml/2006/diagram" xmlns:o="urn:schemas-microsoft-com:office:office" xmlns:v="urn:schemas-microsoft-com:vml" xmlns:pvml="urn:schemas-microsoft-com:office:powerpoint" xmlns:com="http://schemas.openxmlformats.org/drawingml/2006/compatibility" xmlns:p15="http://schemas.microsoft.com/office/powerpoint/2012/main" xmlns:ahyp="http://schemas.microsoft.com/office/drawing/2018/hyperlinkcolor">
+    <mc:Fallback xmlns:ahyp="http://schemas.microsoft.com/office/drawing/2018/hyperlinkcolor" xmlns:p15="http://schemas.microsoft.com/office/powerpoint/2012/main" xmlns:com="http://schemas.openxmlformats.org/drawingml/2006/compatibility" xmlns:pvml="urn:schemas-microsoft-com:office:powerpoint" xmlns:v="urn:schemas-microsoft-com:vml" xmlns:o="urn:schemas-microsoft-com:office:office" xmlns:dgm="http://schemas.openxmlformats.org/drawingml/2006/diagram" xmlns:c="http://schemas.openxmlformats.org/drawingml/2006/chart" xmlns:mv="urn:schemas-microsoft-com:mac:vml" xmlns="">
       <p:transition spd="slow">
         <p:fade/>
       </p:transition>

</xml_diff>